<commit_message>
docs: refine project status report typography
Co-authored-by: 程序员鱼皮 <592789970@qq.com>
</commit_message>
<xml_diff>
--- a/docs/reports/project-status-2026-06-19.pptx
+++ b/docs/reports/project-status-2026-06-19.pptx
@@ -1700,6 +1700,10 @@
             <a:prstDash val="solid"/>
           </a:ln>
         </p:spPr>
+        <p:txBody>
+          <a:bodyPr/>
+          <a:p/>
+        </p:txBody>
       </p:sp>
       <p:sp>
         <p:nvSpPr>
@@ -1729,6 +1733,10 @@
             <a:prstDash val="solid"/>
           </a:ln>
         </p:spPr>
+        <p:txBody>
+          <a:bodyPr/>
+          <a:p/>
+        </p:txBody>
       </p:sp>
       <p:sp>
         <p:nvSpPr>
@@ -1758,6 +1766,10 @@
             <a:prstDash val="solid"/>
           </a:ln>
         </p:spPr>
+        <p:txBody>
+          <a:bodyPr/>
+          <a:p/>
+        </p:txBody>
       </p:sp>
       <p:sp>
         <p:nvSpPr>
@@ -1787,6 +1799,10 @@
             <a:prstDash val="solid"/>
           </a:ln>
         </p:spPr>
+        <p:txBody>
+          <a:bodyPr/>
+          <a:p/>
+        </p:txBody>
       </p:sp>
       <p:sp>
         <p:nvSpPr>
@@ -1925,6 +1941,10 @@
             <a:prstDash val="solid"/>
           </a:ln>
         </p:spPr>
+        <p:txBody>
+          <a:bodyPr/>
+          <a:p/>
+        </p:txBody>
       </p:sp>
       <p:sp>
         <p:nvSpPr>
@@ -1986,6 +2006,10 @@
             <a:prstDash val="solid"/>
           </a:ln>
         </p:spPr>
+        <p:txBody>
+          <a:bodyPr/>
+          <a:p/>
+        </p:txBody>
       </p:sp>
       <p:sp>
         <p:nvSpPr>
@@ -2011,6 +2035,10 @@
             <a:prstDash val="solid"/>
           </a:ln>
         </p:spPr>
+        <p:txBody>
+          <a:bodyPr/>
+          <a:p/>
+        </p:txBody>
       </p:sp>
       <p:sp>
         <p:nvSpPr>
@@ -2036,6 +2064,10 @@
             <a:prstDash val="solid"/>
           </a:ln>
         </p:spPr>
+        <p:txBody>
+          <a:bodyPr/>
+          <a:p/>
+        </p:txBody>
       </p:sp>
       <p:sp>
         <p:nvSpPr>
@@ -2061,6 +2093,10 @@
             <a:prstDash val="solid"/>
           </a:ln>
         </p:spPr>
+        <p:txBody>
+          <a:bodyPr/>
+          <a:p/>
+        </p:txBody>
       </p:sp>
       <p:sp>
         <p:nvSpPr>
@@ -2086,6 +2122,10 @@
             <a:prstDash val="solid"/>
           </a:ln>
         </p:spPr>
+        <p:txBody>
+          <a:bodyPr/>
+          <a:p/>
+        </p:txBody>
       </p:sp>
       <p:sp>
         <p:nvSpPr>
@@ -2111,6 +2151,10 @@
             <a:prstDash val="solid"/>
           </a:ln>
         </p:spPr>
+        <p:txBody>
+          <a:bodyPr/>
+          <a:p/>
+        </p:txBody>
       </p:sp>
       <p:sp>
         <p:nvSpPr>
@@ -2138,6 +2182,10 @@
             <a:prstDash val="solid"/>
           </a:ln>
         </p:spPr>
+        <p:txBody>
+          <a:bodyPr/>
+          <a:p/>
+        </p:txBody>
       </p:sp>
       <p:sp>
         <p:nvSpPr>
@@ -2165,6 +2213,10 @@
             <a:prstDash val="solid"/>
           </a:ln>
         </p:spPr>
+        <p:txBody>
+          <a:bodyPr/>
+          <a:p/>
+        </p:txBody>
       </p:sp>
       <p:sp>
         <p:nvSpPr>
@@ -2192,6 +2244,10 @@
             <a:prstDash val="solid"/>
           </a:ln>
         </p:spPr>
+        <p:txBody>
+          <a:bodyPr/>
+          <a:p/>
+        </p:txBody>
       </p:sp>
       <p:sp>
         <p:nvSpPr>
@@ -2219,6 +2275,10 @@
             <a:prstDash val="solid"/>
           </a:ln>
         </p:spPr>
+        <p:txBody>
+          <a:bodyPr/>
+          <a:p/>
+        </p:txBody>
       </p:sp>
       <p:sp>
         <p:nvSpPr>
@@ -2246,6 +2306,10 @@
             <a:prstDash val="solid"/>
           </a:ln>
         </p:spPr>
+        <p:txBody>
+          <a:bodyPr/>
+          <a:p/>
+        </p:txBody>
       </p:sp>
       <p:sp>
         <p:nvSpPr>
@@ -2273,6 +2337,10 @@
             <a:prstDash val="solid"/>
           </a:ln>
         </p:spPr>
+        <p:txBody>
+          <a:bodyPr/>
+          <a:p/>
+        </p:txBody>
       </p:sp>
       <p:sp>
         <p:nvSpPr>
@@ -2300,6 +2368,10 @@
             <a:prstDash val="solid"/>
           </a:ln>
         </p:spPr>
+        <p:txBody>
+          <a:bodyPr/>
+          <a:p/>
+        </p:txBody>
       </p:sp>
       <p:sp>
         <p:nvSpPr>
@@ -2393,6 +2465,10 @@
             <a:prstDash val="solid"/>
           </a:ln>
         </p:spPr>
+        <p:txBody>
+          <a:bodyPr/>
+          <a:p/>
+        </p:txBody>
       </p:sp>
       <p:sp>
         <p:nvSpPr>
@@ -2422,6 +2498,10 @@
             <a:prstDash val="solid"/>
           </a:ln>
         </p:spPr>
+        <p:txBody>
+          <a:bodyPr/>
+          <a:p/>
+        </p:txBody>
       </p:sp>
       <p:sp>
         <p:nvSpPr>
@@ -2451,6 +2531,10 @@
             <a:prstDash val="solid"/>
           </a:ln>
         </p:spPr>
+        <p:txBody>
+          <a:bodyPr/>
+          <a:p/>
+        </p:txBody>
       </p:sp>
       <p:sp>
         <p:nvSpPr>
@@ -2480,6 +2564,10 @@
             <a:prstDash val="solid"/>
           </a:ln>
         </p:spPr>
+        <p:txBody>
+          <a:bodyPr/>
+          <a:p/>
+        </p:txBody>
       </p:sp>
       <p:sp>
         <p:nvSpPr>
@@ -2586,6 +2674,10 @@
             <a:prstDash val="solid"/>
           </a:ln>
         </p:spPr>
+        <p:txBody>
+          <a:bodyPr/>
+          <a:p/>
+        </p:txBody>
       </p:sp>
       <p:sp>
         <p:nvSpPr>
@@ -2691,6 +2783,10 @@
             <a:prstDash val="solid"/>
           </a:ln>
         </p:spPr>
+        <p:txBody>
+          <a:bodyPr/>
+          <a:p/>
+        </p:txBody>
       </p:sp>
       <p:sp>
         <p:nvSpPr>
@@ -2794,6 +2890,10 @@
             <a:prstDash val="solid"/>
           </a:ln>
         </p:spPr>
+        <p:txBody>
+          <a:bodyPr/>
+          <a:p/>
+        </p:txBody>
       </p:sp>
       <p:sp>
         <p:nvSpPr>
@@ -2895,6 +2995,10 @@
             <a:prstDash val="solid"/>
           </a:ln>
         </p:spPr>
+        <p:txBody>
+          <a:bodyPr/>
+          <a:p/>
+        </p:txBody>
       </p:sp>
       <p:sp>
         <p:nvSpPr>
@@ -2988,6 +3092,10 @@
             <a:prstDash val="solid"/>
           </a:ln>
         </p:spPr>
+        <p:txBody>
+          <a:bodyPr/>
+          <a:p/>
+        </p:txBody>
       </p:sp>
       <p:sp>
         <p:nvSpPr>
@@ -3013,6 +3121,10 @@
             <a:prstDash val="solid"/>
           </a:ln>
         </p:spPr>
+        <p:txBody>
+          <a:bodyPr/>
+          <a:p/>
+        </p:txBody>
       </p:sp>
       <p:sp>
         <p:nvSpPr>
@@ -3038,6 +3150,10 @@
             <a:prstDash val="solid"/>
           </a:ln>
         </p:spPr>
+        <p:txBody>
+          <a:bodyPr/>
+          <a:p/>
+        </p:txBody>
       </p:sp>
       <p:sp>
         <p:nvSpPr>
@@ -3067,6 +3183,10 @@
             <a:prstDash val="solid"/>
           </a:ln>
         </p:spPr>
+        <p:txBody>
+          <a:bodyPr/>
+          <a:p/>
+        </p:txBody>
       </p:sp>
       <p:sp>
         <p:nvSpPr>
@@ -3077,7 +3197,7 @@
         <p:spPr>
           <a:xfrm>
             <a:off x="658368" y="320040"/>
-            <a:ext cx="8046720" cy="457200"/>
+            <a:ext cx="8046720" cy="658368"/>
           </a:xfrm>
           <a:prstGeom prst="rect">
             <a:avLst/>
@@ -3093,7 +3213,7 @@
               <a:buNone/>
             </a:pPr>
             <a:r>
-              <a:rPr lang="en-US" sz="3000" b="1" dirty="0">
+              <a:rPr lang="en-US" sz="3600" b="1" dirty="0">
                 <a:solidFill>
                   <a:srgbClr val="065A82"/>
                 </a:solidFill>
@@ -3172,6 +3292,10 @@
             <a:prstDash val="solid"/>
           </a:ln>
         </p:spPr>
+        <p:txBody>
+          <a:bodyPr/>
+          <a:p/>
+        </p:txBody>
       </p:sp>
       <p:sp>
         <p:nvSpPr>
@@ -3235,6 +3359,10 @@
             <a:prstDash val="solid"/>
           </a:ln>
         </p:spPr>
+        <p:txBody>
+          <a:bodyPr/>
+          <a:p/>
+        </p:txBody>
       </p:sp>
       <p:sp>
         <p:nvSpPr>
@@ -3336,6 +3464,10 @@
             <a:prstDash val="solid"/>
           </a:ln>
         </p:spPr>
+        <p:txBody>
+          <a:bodyPr/>
+          <a:p/>
+        </p:txBody>
       </p:sp>
       <p:sp>
         <p:nvSpPr>
@@ -3399,6 +3531,10 @@
             <a:prstDash val="solid"/>
           </a:ln>
         </p:spPr>
+        <p:txBody>
+          <a:bodyPr/>
+          <a:p/>
+        </p:txBody>
       </p:sp>
       <p:sp>
         <p:nvSpPr>
@@ -3424,6 +3560,10 @@
             <a:prstDash val="solid"/>
           </a:ln>
         </p:spPr>
+        <p:txBody>
+          <a:bodyPr/>
+          <a:p/>
+        </p:txBody>
       </p:sp>
       <p:sp>
         <p:nvSpPr>
@@ -3525,6 +3665,10 @@
             <a:prstDash val="solid"/>
           </a:ln>
         </p:spPr>
+        <p:txBody>
+          <a:bodyPr/>
+          <a:p/>
+        </p:txBody>
       </p:sp>
       <p:sp>
         <p:nvSpPr>
@@ -3550,6 +3694,10 @@
             <a:prstDash val="solid"/>
           </a:ln>
         </p:spPr>
+        <p:txBody>
+          <a:bodyPr/>
+          <a:p/>
+        </p:txBody>
       </p:sp>
       <p:sp>
         <p:nvSpPr>
@@ -3651,6 +3799,10 @@
             <a:prstDash val="solid"/>
           </a:ln>
         </p:spPr>
+        <p:txBody>
+          <a:bodyPr/>
+          <a:p/>
+        </p:txBody>
       </p:sp>
       <p:sp>
         <p:nvSpPr>
@@ -3676,6 +3828,10 @@
             <a:prstDash val="solid"/>
           </a:ln>
         </p:spPr>
+        <p:txBody>
+          <a:bodyPr/>
+          <a:p/>
+        </p:txBody>
       </p:sp>
       <p:sp>
         <p:nvSpPr>
@@ -3777,6 +3933,10 @@
             <a:prstDash val="solid"/>
           </a:ln>
         </p:spPr>
+        <p:txBody>
+          <a:bodyPr/>
+          <a:p/>
+        </p:txBody>
       </p:sp>
       <p:sp>
         <p:nvSpPr>
@@ -3802,6 +3962,10 @@
             <a:prstDash val="solid"/>
           </a:ln>
         </p:spPr>
+        <p:txBody>
+          <a:bodyPr/>
+          <a:p/>
+        </p:txBody>
       </p:sp>
       <p:sp>
         <p:nvSpPr>
@@ -4005,6 +4169,10 @@
             <a:prstDash val="solid"/>
           </a:ln>
         </p:spPr>
+        <p:txBody>
+          <a:bodyPr/>
+          <a:p/>
+        </p:txBody>
       </p:sp>
       <p:sp>
         <p:nvSpPr>
@@ -4030,6 +4198,10 @@
             <a:prstDash val="solid"/>
           </a:ln>
         </p:spPr>
+        <p:txBody>
+          <a:bodyPr/>
+          <a:p/>
+        </p:txBody>
       </p:sp>
       <p:sp>
         <p:nvSpPr>
@@ -4055,6 +4227,10 @@
             <a:prstDash val="solid"/>
           </a:ln>
         </p:spPr>
+        <p:txBody>
+          <a:bodyPr/>
+          <a:p/>
+        </p:txBody>
       </p:sp>
       <p:sp>
         <p:nvSpPr>
@@ -4084,6 +4260,10 @@
             <a:prstDash val="solid"/>
           </a:ln>
         </p:spPr>
+        <p:txBody>
+          <a:bodyPr/>
+          <a:p/>
+        </p:txBody>
       </p:sp>
       <p:sp>
         <p:nvSpPr>
@@ -4094,7 +4274,7 @@
         <p:spPr>
           <a:xfrm>
             <a:off x="658368" y="320040"/>
-            <a:ext cx="8046720" cy="457200"/>
+            <a:ext cx="8046720" cy="658368"/>
           </a:xfrm>
           <a:prstGeom prst="rect">
             <a:avLst/>
@@ -4110,7 +4290,7 @@
               <a:buNone/>
             </a:pPr>
             <a:r>
-              <a:rPr lang="en-US" sz="3000" b="1" dirty="0">
+              <a:rPr lang="en-US" sz="3600" b="1" dirty="0">
                 <a:solidFill>
                   <a:srgbClr val="065A82"/>
                 </a:solidFill>
@@ -4189,6 +4369,10 @@
             <a:prstDash val="solid"/>
           </a:ln>
         </p:spPr>
+        <p:txBody>
+          <a:bodyPr/>
+          <a:p/>
+        </p:txBody>
       </p:sp>
       <p:sp>
         <p:nvSpPr>
@@ -4252,6 +4436,10 @@
             <a:prstDash val="solid"/>
           </a:ln>
         </p:spPr>
+        <p:txBody>
+          <a:bodyPr/>
+          <a:p/>
+        </p:txBody>
       </p:sp>
       <p:sp>
         <p:nvSpPr>
@@ -4277,6 +4465,10 @@
             <a:prstDash val="solid"/>
           </a:ln>
         </p:spPr>
+        <p:txBody>
+          <a:bodyPr/>
+          <a:p/>
+        </p:txBody>
       </p:sp>
       <p:sp>
         <p:nvSpPr>
@@ -4302,6 +4494,10 @@
             <a:prstDash val="solid"/>
           </a:ln>
         </p:spPr>
+        <p:txBody>
+          <a:bodyPr/>
+          <a:p/>
+        </p:txBody>
       </p:sp>
       <p:sp>
         <p:nvSpPr>
@@ -4439,6 +4635,10 @@
             <a:prstDash val="solid"/>
           </a:ln>
         </p:spPr>
+        <p:txBody>
+          <a:bodyPr/>
+          <a:p/>
+        </p:txBody>
       </p:sp>
       <p:sp>
         <p:nvSpPr>
@@ -4464,6 +4664,10 @@
             <a:prstDash val="solid"/>
           </a:ln>
         </p:spPr>
+        <p:txBody>
+          <a:bodyPr/>
+          <a:p/>
+        </p:txBody>
       </p:sp>
       <p:sp>
         <p:nvSpPr>
@@ -4489,6 +4693,10 @@
             <a:prstDash val="solid"/>
           </a:ln>
         </p:spPr>
+        <p:txBody>
+          <a:bodyPr/>
+          <a:p/>
+        </p:txBody>
       </p:sp>
       <p:sp>
         <p:nvSpPr>
@@ -4626,6 +4834,10 @@
             <a:prstDash val="solid"/>
           </a:ln>
         </p:spPr>
+        <p:txBody>
+          <a:bodyPr/>
+          <a:p/>
+        </p:txBody>
       </p:sp>
       <p:sp>
         <p:nvSpPr>
@@ -4651,6 +4863,10 @@
             <a:prstDash val="solid"/>
           </a:ln>
         </p:spPr>
+        <p:txBody>
+          <a:bodyPr/>
+          <a:p/>
+        </p:txBody>
       </p:sp>
       <p:sp>
         <p:nvSpPr>
@@ -4676,6 +4892,10 @@
             <a:prstDash val="solid"/>
           </a:ln>
         </p:spPr>
+        <p:txBody>
+          <a:bodyPr/>
+          <a:p/>
+        </p:txBody>
       </p:sp>
       <p:sp>
         <p:nvSpPr>
@@ -4813,6 +5033,10 @@
             <a:prstDash val="solid"/>
           </a:ln>
         </p:spPr>
+        <p:txBody>
+          <a:bodyPr/>
+          <a:p/>
+        </p:txBody>
       </p:sp>
       <p:sp>
         <p:nvSpPr>
@@ -4838,6 +5062,10 @@
             <a:prstDash val="solid"/>
           </a:ln>
         </p:spPr>
+        <p:txBody>
+          <a:bodyPr/>
+          <a:p/>
+        </p:txBody>
       </p:sp>
       <p:sp>
         <p:nvSpPr>
@@ -4863,6 +5091,10 @@
             <a:prstDash val="solid"/>
           </a:ln>
         </p:spPr>
+        <p:txBody>
+          <a:bodyPr/>
+          <a:p/>
+        </p:txBody>
       </p:sp>
       <p:sp>
         <p:nvSpPr>
@@ -4998,6 +5230,10 @@
             <a:prstDash val="solid"/>
           </a:ln>
         </p:spPr>
+        <p:txBody>
+          <a:bodyPr/>
+          <a:p/>
+        </p:txBody>
       </p:sp>
       <p:sp>
         <p:nvSpPr>
@@ -5059,6 +5295,10 @@
             <a:prstDash val="solid"/>
           </a:ln>
         </p:spPr>
+        <p:txBody>
+          <a:bodyPr/>
+          <a:p/>
+        </p:txBody>
       </p:sp>
       <p:sp>
         <p:nvSpPr>
@@ -5120,6 +5360,10 @@
             <a:prstDash val="solid"/>
           </a:ln>
         </p:spPr>
+        <p:txBody>
+          <a:bodyPr/>
+          <a:p/>
+        </p:txBody>
       </p:sp>
       <p:sp>
         <p:nvSpPr>
@@ -5181,6 +5425,10 @@
             <a:prstDash val="solid"/>
           </a:ln>
         </p:spPr>
+        <p:txBody>
+          <a:bodyPr/>
+          <a:p/>
+        </p:txBody>
       </p:sp>
       <p:sp>
         <p:nvSpPr>
@@ -5242,6 +5490,10 @@
             <a:prstDash val="solid"/>
           </a:ln>
         </p:spPr>
+        <p:txBody>
+          <a:bodyPr/>
+          <a:p/>
+        </p:txBody>
       </p:sp>
       <p:sp>
         <p:nvSpPr>
@@ -5407,6 +5659,10 @@
             <a:prstDash val="solid"/>
           </a:ln>
         </p:spPr>
+        <p:txBody>
+          <a:bodyPr/>
+          <a:p/>
+        </p:txBody>
       </p:sp>
       <p:sp>
         <p:nvSpPr>
@@ -5432,6 +5688,10 @@
             <a:prstDash val="solid"/>
           </a:ln>
         </p:spPr>
+        <p:txBody>
+          <a:bodyPr/>
+          <a:p/>
+        </p:txBody>
       </p:sp>
       <p:sp>
         <p:nvSpPr>
@@ -5457,6 +5717,10 @@
             <a:prstDash val="solid"/>
           </a:ln>
         </p:spPr>
+        <p:txBody>
+          <a:bodyPr/>
+          <a:p/>
+        </p:txBody>
       </p:sp>
       <p:sp>
         <p:nvSpPr>
@@ -5486,6 +5750,10 @@
             <a:prstDash val="solid"/>
           </a:ln>
         </p:spPr>
+        <p:txBody>
+          <a:bodyPr/>
+          <a:p/>
+        </p:txBody>
       </p:sp>
       <p:sp>
         <p:nvSpPr>
@@ -5496,7 +5764,7 @@
         <p:spPr>
           <a:xfrm>
             <a:off x="658368" y="320040"/>
-            <a:ext cx="8046720" cy="457200"/>
+            <a:ext cx="8046720" cy="658368"/>
           </a:xfrm>
           <a:prstGeom prst="rect">
             <a:avLst/>
@@ -5512,7 +5780,7 @@
               <a:buNone/>
             </a:pPr>
             <a:r>
-              <a:rPr lang="en-US" sz="3000" b="1" dirty="0">
+              <a:rPr lang="en-US" sz="3600" b="1" dirty="0">
                 <a:solidFill>
                   <a:srgbClr val="065A82"/>
                 </a:solidFill>
@@ -5591,6 +5859,10 @@
             <a:prstDash val="solid"/>
           </a:ln>
         </p:spPr>
+        <p:txBody>
+          <a:bodyPr/>
+          <a:p/>
+        </p:txBody>
       </p:sp>
       <p:sp>
         <p:nvSpPr>
@@ -5654,6 +5926,10 @@
             <a:prstDash val="solid"/>
           </a:ln>
         </p:spPr>
+        <p:txBody>
+          <a:bodyPr/>
+          <a:p/>
+        </p:txBody>
       </p:sp>
       <p:sp>
         <p:nvSpPr>
@@ -5715,6 +5991,10 @@
             <a:prstDash val="solid"/>
           </a:ln>
         </p:spPr>
+        <p:txBody>
+          <a:bodyPr/>
+          <a:p/>
+        </p:txBody>
       </p:sp>
       <p:sp>
         <p:nvSpPr>
@@ -5742,6 +6022,10 @@
             <a:prstDash val="solid"/>
           </a:ln>
         </p:spPr>
+        <p:txBody>
+          <a:bodyPr/>
+          <a:p/>
+        </p:txBody>
       </p:sp>
       <p:sp>
         <p:nvSpPr>
@@ -5767,6 +6051,10 @@
             <a:prstDash val="solid"/>
           </a:ln>
         </p:spPr>
+        <p:txBody>
+          <a:bodyPr/>
+          <a:p/>
+        </p:txBody>
       </p:sp>
       <p:sp>
         <p:nvSpPr>
@@ -5866,6 +6154,10 @@
             <a:prstDash val="solid"/>
           </a:ln>
         </p:spPr>
+        <p:txBody>
+          <a:bodyPr/>
+          <a:p/>
+        </p:txBody>
       </p:sp>
       <p:sp>
         <p:nvSpPr>
@@ -5927,6 +6219,10 @@
             <a:prstDash val="solid"/>
           </a:ln>
         </p:spPr>
+        <p:txBody>
+          <a:bodyPr/>
+          <a:p/>
+        </p:txBody>
       </p:sp>
       <p:sp>
         <p:nvSpPr>
@@ -5988,6 +6284,10 @@
             <a:prstDash val="solid"/>
           </a:ln>
         </p:spPr>
+        <p:txBody>
+          <a:bodyPr/>
+          <a:p/>
+        </p:txBody>
       </p:sp>
       <p:sp>
         <p:nvSpPr>
@@ -6049,6 +6349,10 @@
             <a:prstDash val="solid"/>
           </a:ln>
         </p:spPr>
+        <p:txBody>
+          <a:bodyPr/>
+          <a:p/>
+        </p:txBody>
       </p:sp>
       <p:sp>
         <p:nvSpPr>
@@ -6110,6 +6414,10 @@
             <a:prstDash val="solid"/>
           </a:ln>
         </p:spPr>
+        <p:txBody>
+          <a:bodyPr/>
+          <a:p/>
+        </p:txBody>
       </p:sp>
       <p:sp>
         <p:nvSpPr>
@@ -6137,6 +6445,10 @@
             <a:prstDash val="solid"/>
           </a:ln>
         </p:spPr>
+        <p:txBody>
+          <a:bodyPr/>
+          <a:p/>
+        </p:txBody>
       </p:sp>
       <p:sp>
         <p:nvSpPr>
@@ -6162,6 +6474,10 @@
             <a:prstDash val="solid"/>
           </a:ln>
         </p:spPr>
+        <p:txBody>
+          <a:bodyPr/>
+          <a:p/>
+        </p:txBody>
       </p:sp>
       <p:sp>
         <p:nvSpPr>
@@ -6261,6 +6577,10 @@
             <a:prstDash val="solid"/>
           </a:ln>
         </p:spPr>
+        <p:txBody>
+          <a:bodyPr/>
+          <a:p/>
+        </p:txBody>
       </p:sp>
       <p:sp>
         <p:nvSpPr>
@@ -6322,6 +6642,10 @@
             <a:prstDash val="solid"/>
           </a:ln>
         </p:spPr>
+        <p:txBody>
+          <a:bodyPr/>
+          <a:p/>
+        </p:txBody>
       </p:sp>
       <p:sp>
         <p:nvSpPr>
@@ -6383,6 +6707,10 @@
             <a:prstDash val="solid"/>
           </a:ln>
         </p:spPr>
+        <p:txBody>
+          <a:bodyPr/>
+          <a:p/>
+        </p:txBody>
       </p:sp>
       <p:sp>
         <p:nvSpPr>
@@ -6444,6 +6772,10 @@
             <a:prstDash val="solid"/>
           </a:ln>
         </p:spPr>
+        <p:txBody>
+          <a:bodyPr/>
+          <a:p/>
+        </p:txBody>
       </p:sp>
       <p:sp>
         <p:nvSpPr>
@@ -6505,6 +6837,10 @@
             <a:prstDash val="solid"/>
           </a:ln>
         </p:spPr>
+        <p:txBody>
+          <a:bodyPr/>
+          <a:p/>
+        </p:txBody>
       </p:sp>
       <p:sp>
         <p:nvSpPr>
@@ -6532,6 +6868,10 @@
             <a:prstDash val="solid"/>
           </a:ln>
         </p:spPr>
+        <p:txBody>
+          <a:bodyPr/>
+          <a:p/>
+        </p:txBody>
       </p:sp>
       <p:sp>
         <p:nvSpPr>
@@ -6557,6 +6897,10 @@
             <a:prstDash val="solid"/>
           </a:ln>
         </p:spPr>
+        <p:txBody>
+          <a:bodyPr/>
+          <a:p/>
+        </p:txBody>
       </p:sp>
       <p:sp>
         <p:nvSpPr>
@@ -6656,6 +7000,10 @@
             <a:prstDash val="solid"/>
           </a:ln>
         </p:spPr>
+        <p:txBody>
+          <a:bodyPr/>
+          <a:p/>
+        </p:txBody>
       </p:sp>
       <p:sp>
         <p:nvSpPr>
@@ -6717,6 +7065,10 @@
             <a:prstDash val="solid"/>
           </a:ln>
         </p:spPr>
+        <p:txBody>
+          <a:bodyPr/>
+          <a:p/>
+        </p:txBody>
       </p:sp>
       <p:sp>
         <p:nvSpPr>
@@ -6778,6 +7130,10 @@
             <a:prstDash val="solid"/>
           </a:ln>
         </p:spPr>
+        <p:txBody>
+          <a:bodyPr/>
+          <a:p/>
+        </p:txBody>
       </p:sp>
       <p:sp>
         <p:nvSpPr>
@@ -6839,6 +7195,10 @@
             <a:prstDash val="solid"/>
           </a:ln>
         </p:spPr>
+        <p:txBody>
+          <a:bodyPr/>
+          <a:p/>
+        </p:txBody>
       </p:sp>
       <p:sp>
         <p:nvSpPr>
@@ -7004,6 +7364,10 @@
             <a:prstDash val="solid"/>
           </a:ln>
         </p:spPr>
+        <p:txBody>
+          <a:bodyPr/>
+          <a:p/>
+        </p:txBody>
       </p:sp>
       <p:sp>
         <p:nvSpPr>
@@ -7029,6 +7393,10 @@
             <a:prstDash val="solid"/>
           </a:ln>
         </p:spPr>
+        <p:txBody>
+          <a:bodyPr/>
+          <a:p/>
+        </p:txBody>
       </p:sp>
       <p:sp>
         <p:nvSpPr>
@@ -7054,6 +7422,10 @@
             <a:prstDash val="solid"/>
           </a:ln>
         </p:spPr>
+        <p:txBody>
+          <a:bodyPr/>
+          <a:p/>
+        </p:txBody>
       </p:sp>
       <p:sp>
         <p:nvSpPr>
@@ -7083,6 +7455,10 @@
             <a:prstDash val="solid"/>
           </a:ln>
         </p:spPr>
+        <p:txBody>
+          <a:bodyPr/>
+          <a:p/>
+        </p:txBody>
       </p:sp>
       <p:sp>
         <p:nvSpPr>
@@ -7093,7 +7469,7 @@
         <p:spPr>
           <a:xfrm>
             <a:off x="658368" y="320040"/>
-            <a:ext cx="8046720" cy="457200"/>
+            <a:ext cx="8046720" cy="658368"/>
           </a:xfrm>
           <a:prstGeom prst="rect">
             <a:avLst/>
@@ -7109,7 +7485,7 @@
               <a:buNone/>
             </a:pPr>
             <a:r>
-              <a:rPr lang="en-US" sz="3000" b="1" dirty="0">
+              <a:rPr lang="en-US" sz="3600" b="1" dirty="0">
                 <a:solidFill>
                   <a:srgbClr val="065A82"/>
                 </a:solidFill>
@@ -7188,6 +7564,10 @@
             <a:prstDash val="solid"/>
           </a:ln>
         </p:spPr>
+        <p:txBody>
+          <a:bodyPr/>
+          <a:p/>
+        </p:txBody>
       </p:sp>
       <p:sp>
         <p:nvSpPr>
@@ -7251,6 +7631,10 @@
             <a:prstDash val="solid"/>
           </a:ln>
         </p:spPr>
+        <p:txBody>
+          <a:bodyPr/>
+          <a:p/>
+        </p:txBody>
       </p:sp>
       <p:sp>
         <p:nvSpPr>
@@ -7423,6 +7807,10 @@
             <a:prstDash val="solid"/>
           </a:ln>
         </p:spPr>
+        <p:txBody>
+          <a:bodyPr/>
+          <a:p/>
+        </p:txBody>
       </p:sp>
       <p:sp>
         <p:nvSpPr>
@@ -7448,6 +7836,10 @@
             <a:prstDash val="solid"/>
           </a:ln>
         </p:spPr>
+        <p:txBody>
+          <a:bodyPr/>
+          <a:p/>
+        </p:txBody>
       </p:sp>
       <p:sp>
         <p:nvSpPr>
@@ -7583,6 +7975,10 @@
             <a:prstDash val="solid"/>
           </a:ln>
         </p:spPr>
+        <p:txBody>
+          <a:bodyPr/>
+          <a:p/>
+        </p:txBody>
       </p:sp>
       <p:sp>
         <p:nvSpPr>
@@ -7718,6 +8114,10 @@
             <a:prstDash val="solid"/>
           </a:ln>
         </p:spPr>
+        <p:txBody>
+          <a:bodyPr/>
+          <a:p/>
+        </p:txBody>
       </p:sp>
       <p:sp>
         <p:nvSpPr>
@@ -7855,6 +8255,10 @@
             <a:prstDash val="solid"/>
           </a:ln>
         </p:spPr>
+        <p:txBody>
+          <a:bodyPr/>
+          <a:p/>
+        </p:txBody>
       </p:sp>
       <p:sp>
         <p:nvSpPr>
@@ -8020,6 +8424,10 @@
             <a:prstDash val="solid"/>
           </a:ln>
         </p:spPr>
+        <p:txBody>
+          <a:bodyPr/>
+          <a:p/>
+        </p:txBody>
       </p:sp>
       <p:sp>
         <p:nvSpPr>
@@ -8045,6 +8453,10 @@
             <a:prstDash val="solid"/>
           </a:ln>
         </p:spPr>
+        <p:txBody>
+          <a:bodyPr/>
+          <a:p/>
+        </p:txBody>
       </p:sp>
       <p:sp>
         <p:nvSpPr>
@@ -8070,6 +8482,10 @@
             <a:prstDash val="solid"/>
           </a:ln>
         </p:spPr>
+        <p:txBody>
+          <a:bodyPr/>
+          <a:p/>
+        </p:txBody>
       </p:sp>
       <p:sp>
         <p:nvSpPr>
@@ -8099,6 +8515,10 @@
             <a:prstDash val="solid"/>
           </a:ln>
         </p:spPr>
+        <p:txBody>
+          <a:bodyPr/>
+          <a:p/>
+        </p:txBody>
       </p:sp>
       <p:sp>
         <p:nvSpPr>
@@ -8109,7 +8529,7 @@
         <p:spPr>
           <a:xfrm>
             <a:off x="658368" y="320040"/>
-            <a:ext cx="8046720" cy="457200"/>
+            <a:ext cx="8046720" cy="658368"/>
           </a:xfrm>
           <a:prstGeom prst="rect">
             <a:avLst/>
@@ -8125,7 +8545,7 @@
               <a:buNone/>
             </a:pPr>
             <a:r>
-              <a:rPr lang="en-US" sz="3000" b="1" dirty="0">
+              <a:rPr lang="en-US" sz="3600" b="1" dirty="0">
                 <a:solidFill>
                   <a:srgbClr val="065A82"/>
                 </a:solidFill>
@@ -8204,6 +8624,10 @@
             <a:prstDash val="solid"/>
           </a:ln>
         </p:spPr>
+        <p:txBody>
+          <a:bodyPr/>
+          <a:p/>
+        </p:txBody>
       </p:sp>
       <p:sp>
         <p:nvSpPr>
@@ -8267,6 +8691,10 @@
             <a:prstDash val="solid"/>
           </a:ln>
         </p:spPr>
+        <p:txBody>
+          <a:bodyPr/>
+          <a:p/>
+        </p:txBody>
       </p:sp>
       <p:sp>
         <p:nvSpPr>
@@ -8407,6 +8835,10 @@
             <a:prstDash val="solid"/>
           </a:ln>
         </p:spPr>
+        <p:txBody>
+          <a:bodyPr/>
+          <a:p/>
+        </p:txBody>
       </p:sp>
       <p:sp>
         <p:nvSpPr>
@@ -8547,6 +8979,10 @@
             <a:prstDash val="solid"/>
           </a:ln>
         </p:spPr>
+        <p:txBody>
+          <a:bodyPr/>
+          <a:p/>
+        </p:txBody>
       </p:sp>
       <p:sp>
         <p:nvSpPr>
@@ -8687,6 +9123,10 @@
             <a:prstDash val="solid"/>
           </a:ln>
         </p:spPr>
+        <p:txBody>
+          <a:bodyPr/>
+          <a:p/>
+        </p:txBody>
       </p:sp>
       <p:sp>
         <p:nvSpPr>
@@ -8827,6 +9267,10 @@
             <a:prstDash val="solid"/>
           </a:ln>
         </p:spPr>
+        <p:txBody>
+          <a:bodyPr/>
+          <a:p/>
+        </p:txBody>
       </p:sp>
       <p:sp>
         <p:nvSpPr>
@@ -8928,6 +9372,10 @@
             <a:prstDash val="solid"/>
           </a:ln>
         </p:spPr>
+        <p:txBody>
+          <a:bodyPr/>
+          <a:p/>
+        </p:txBody>
       </p:sp>
       <p:sp>
         <p:nvSpPr>
@@ -9131,6 +9579,10 @@
             <a:prstDash val="solid"/>
           </a:ln>
         </p:spPr>
+        <p:txBody>
+          <a:bodyPr/>
+          <a:p/>
+        </p:txBody>
       </p:sp>
       <p:sp>
         <p:nvSpPr>
@@ -9156,6 +9608,10 @@
             <a:prstDash val="solid"/>
           </a:ln>
         </p:spPr>
+        <p:txBody>
+          <a:bodyPr/>
+          <a:p/>
+        </p:txBody>
       </p:sp>
       <p:sp>
         <p:nvSpPr>
@@ -9181,6 +9637,10 @@
             <a:prstDash val="solid"/>
           </a:ln>
         </p:spPr>
+        <p:txBody>
+          <a:bodyPr/>
+          <a:p/>
+        </p:txBody>
       </p:sp>
       <p:sp>
         <p:nvSpPr>
@@ -9210,6 +9670,10 @@
             <a:prstDash val="solid"/>
           </a:ln>
         </p:spPr>
+        <p:txBody>
+          <a:bodyPr/>
+          <a:p/>
+        </p:txBody>
       </p:sp>
       <p:sp>
         <p:nvSpPr>
@@ -9220,7 +9684,7 @@
         <p:spPr>
           <a:xfrm>
             <a:off x="658368" y="320040"/>
-            <a:ext cx="8046720" cy="457200"/>
+            <a:ext cx="8046720" cy="658368"/>
           </a:xfrm>
           <a:prstGeom prst="rect">
             <a:avLst/>
@@ -9236,7 +9700,7 @@
               <a:buNone/>
             </a:pPr>
             <a:r>
-              <a:rPr lang="en-US" sz="3000" b="1" dirty="0">
+              <a:rPr lang="en-US" sz="3600" b="1" dirty="0">
                 <a:solidFill>
                   <a:srgbClr val="065A82"/>
                 </a:solidFill>
@@ -9315,6 +9779,10 @@
             <a:prstDash val="solid"/>
           </a:ln>
         </p:spPr>
+        <p:txBody>
+          <a:bodyPr/>
+          <a:p/>
+        </p:txBody>
       </p:sp>
       <p:sp>
         <p:nvSpPr>
@@ -9376,6 +9844,10 @@
             <a:prstDash val="solid"/>
           </a:ln>
         </p:spPr>
+        <p:txBody>
+          <a:bodyPr/>
+          <a:p/>
+        </p:txBody>
       </p:sp>
       <p:sp>
         <p:nvSpPr>
@@ -9511,6 +9983,10 @@
             <a:prstDash val="solid"/>
           </a:ln>
         </p:spPr>
+        <p:txBody>
+          <a:bodyPr/>
+          <a:p/>
+        </p:txBody>
       </p:sp>
       <p:sp>
         <p:nvSpPr>
@@ -9646,6 +10122,10 @@
             <a:prstDash val="solid"/>
           </a:ln>
         </p:spPr>
+        <p:txBody>
+          <a:bodyPr/>
+          <a:p/>
+        </p:txBody>
       </p:sp>
       <p:sp>
         <p:nvSpPr>
@@ -9781,6 +10261,10 @@
             <a:prstDash val="solid"/>
           </a:ln>
         </p:spPr>
+        <p:txBody>
+          <a:bodyPr/>
+          <a:p/>
+        </p:txBody>
       </p:sp>
       <p:sp>
         <p:nvSpPr>
@@ -9918,6 +10402,10 @@
             <a:prstDash val="solid"/>
           </a:ln>
         </p:spPr>
+        <p:txBody>
+          <a:bodyPr/>
+          <a:p/>
+        </p:txBody>
       </p:sp>
       <p:sp>
         <p:nvSpPr>
@@ -10017,6 +10505,10 @@
             <a:prstDash val="solid"/>
           </a:ln>
         </p:spPr>
+        <p:txBody>
+          <a:bodyPr/>
+          <a:p/>
+        </p:txBody>
       </p:sp>
       <p:sp>
         <p:nvSpPr>
@@ -10044,6 +10536,10 @@
             <a:prstDash val="solid"/>
           </a:ln>
         </p:spPr>
+        <p:txBody>
+          <a:bodyPr/>
+          <a:p/>
+        </p:txBody>
       </p:sp>
       <p:sp>
         <p:nvSpPr>
@@ -10107,6 +10603,10 @@
             <a:prstDash val="solid"/>
           </a:ln>
         </p:spPr>
+        <p:txBody>
+          <a:bodyPr/>
+          <a:p/>
+        </p:txBody>
       </p:sp>
       <p:sp>
         <p:nvSpPr>
@@ -10134,6 +10634,10 @@
             <a:prstDash val="solid"/>
           </a:ln>
         </p:spPr>
+        <p:txBody>
+          <a:bodyPr/>
+          <a:p/>
+        </p:txBody>
       </p:sp>
       <p:sp>
         <p:nvSpPr>
@@ -10197,6 +10701,10 @@
             <a:prstDash val="solid"/>
           </a:ln>
         </p:spPr>
+        <p:txBody>
+          <a:bodyPr/>
+          <a:p/>
+        </p:txBody>
       </p:sp>
       <p:sp>
         <p:nvSpPr>
@@ -10224,6 +10732,10 @@
             <a:prstDash val="solid"/>
           </a:ln>
         </p:spPr>
+        <p:txBody>
+          <a:bodyPr/>
+          <a:p/>
+        </p:txBody>
       </p:sp>
       <p:sp>
         <p:nvSpPr>
@@ -10287,6 +10799,10 @@
             <a:prstDash val="solid"/>
           </a:ln>
         </p:spPr>
+        <p:txBody>
+          <a:bodyPr/>
+          <a:p/>
+        </p:txBody>
       </p:sp>
       <p:sp>
         <p:nvSpPr>
@@ -10314,6 +10830,10 @@
             <a:prstDash val="solid"/>
           </a:ln>
         </p:spPr>
+        <p:txBody>
+          <a:bodyPr/>
+          <a:p/>
+        </p:txBody>
       </p:sp>
       <p:sp>
         <p:nvSpPr>
@@ -10479,6 +10999,10 @@
             <a:prstDash val="solid"/>
           </a:ln>
         </p:spPr>
+        <p:txBody>
+          <a:bodyPr/>
+          <a:p/>
+        </p:txBody>
       </p:sp>
       <p:sp>
         <p:nvSpPr>
@@ -10504,6 +11028,10 @@
             <a:prstDash val="solid"/>
           </a:ln>
         </p:spPr>
+        <p:txBody>
+          <a:bodyPr/>
+          <a:p/>
+        </p:txBody>
       </p:sp>
       <p:sp>
         <p:nvSpPr>
@@ -10529,6 +11057,10 @@
             <a:prstDash val="solid"/>
           </a:ln>
         </p:spPr>
+        <p:txBody>
+          <a:bodyPr/>
+          <a:p/>
+        </p:txBody>
       </p:sp>
       <p:sp>
         <p:nvSpPr>
@@ -10558,6 +11090,10 @@
             <a:prstDash val="solid"/>
           </a:ln>
         </p:spPr>
+        <p:txBody>
+          <a:bodyPr/>
+          <a:p/>
+        </p:txBody>
       </p:sp>
       <p:sp>
         <p:nvSpPr>
@@ -10568,7 +11104,7 @@
         <p:spPr>
           <a:xfrm>
             <a:off x="658368" y="320040"/>
-            <a:ext cx="8046720" cy="457200"/>
+            <a:ext cx="8046720" cy="658368"/>
           </a:xfrm>
           <a:prstGeom prst="rect">
             <a:avLst/>
@@ -10584,7 +11120,7 @@
               <a:buNone/>
             </a:pPr>
             <a:r>
-              <a:rPr lang="en-US" sz="3000" b="1" dirty="0">
+              <a:rPr lang="en-US" sz="3600" b="1" dirty="0">
                 <a:solidFill>
                   <a:srgbClr val="065A82"/>
                 </a:solidFill>
@@ -10663,6 +11199,10 @@
             <a:prstDash val="solid"/>
           </a:ln>
         </p:spPr>
+        <p:txBody>
+          <a:bodyPr/>
+          <a:p/>
+        </p:txBody>
       </p:sp>
       <p:sp>
         <p:nvSpPr>
@@ -10726,6 +11266,10 @@
             <a:prstDash val="solid"/>
           </a:ln>
         </p:spPr>
+        <p:txBody>
+          <a:bodyPr/>
+          <a:p/>
+        </p:txBody>
       </p:sp>
       <p:sp>
         <p:nvSpPr>
@@ -10751,6 +11295,10 @@
             <a:prstDash val="solid"/>
           </a:ln>
         </p:spPr>
+        <p:txBody>
+          <a:bodyPr/>
+          <a:p/>
+        </p:txBody>
       </p:sp>
       <p:sp>
         <p:nvSpPr>
@@ -10888,6 +11436,10 @@
             <a:prstDash val="solid"/>
           </a:ln>
         </p:spPr>
+        <p:txBody>
+          <a:bodyPr/>
+          <a:p/>
+        </p:txBody>
       </p:sp>
       <p:sp>
         <p:nvSpPr>
@@ -10913,6 +11465,10 @@
             <a:prstDash val="solid"/>
           </a:ln>
         </p:spPr>
+        <p:txBody>
+          <a:bodyPr/>
+          <a:p/>
+        </p:txBody>
       </p:sp>
       <p:sp>
         <p:nvSpPr>
@@ -11050,6 +11606,10 @@
             <a:prstDash val="solid"/>
           </a:ln>
         </p:spPr>
+        <p:txBody>
+          <a:bodyPr/>
+          <a:p/>
+        </p:txBody>
       </p:sp>
       <p:sp>
         <p:nvSpPr>
@@ -11075,6 +11635,10 @@
             <a:prstDash val="solid"/>
           </a:ln>
         </p:spPr>
+        <p:txBody>
+          <a:bodyPr/>
+          <a:p/>
+        </p:txBody>
       </p:sp>
       <p:sp>
         <p:nvSpPr>
@@ -11212,6 +11776,10 @@
             <a:prstDash val="solid"/>
           </a:ln>
         </p:spPr>
+        <p:txBody>
+          <a:bodyPr/>
+          <a:p/>
+        </p:txBody>
       </p:sp>
       <p:sp>
         <p:nvSpPr>
@@ -11237,6 +11805,10 @@
             <a:prstDash val="solid"/>
           </a:ln>
         </p:spPr>
+        <p:txBody>
+          <a:bodyPr/>
+          <a:p/>
+        </p:txBody>
       </p:sp>
       <p:sp>
         <p:nvSpPr>
@@ -11374,6 +11946,10 @@
             <a:prstDash val="solid"/>
           </a:ln>
         </p:spPr>
+        <p:txBody>
+          <a:bodyPr/>
+          <a:p/>
+        </p:txBody>
       </p:sp>
       <p:sp>
         <p:nvSpPr>
@@ -11539,6 +12115,10 @@
             <a:prstDash val="solid"/>
           </a:ln>
         </p:spPr>
+        <p:txBody>
+          <a:bodyPr/>
+          <a:p/>
+        </p:txBody>
       </p:sp>
       <p:sp>
         <p:nvSpPr>
@@ -11564,6 +12144,10 @@
             <a:prstDash val="solid"/>
           </a:ln>
         </p:spPr>
+        <p:txBody>
+          <a:bodyPr/>
+          <a:p/>
+        </p:txBody>
       </p:sp>
       <p:sp>
         <p:nvSpPr>
@@ -11589,6 +12173,10 @@
             <a:prstDash val="solid"/>
           </a:ln>
         </p:spPr>
+        <p:txBody>
+          <a:bodyPr/>
+          <a:p/>
+        </p:txBody>
       </p:sp>
       <p:sp>
         <p:nvSpPr>
@@ -11618,6 +12206,10 @@
             <a:prstDash val="solid"/>
           </a:ln>
         </p:spPr>
+        <p:txBody>
+          <a:bodyPr/>
+          <a:p/>
+        </p:txBody>
       </p:sp>
       <p:sp>
         <p:nvSpPr>
@@ -11628,7 +12220,7 @@
         <p:spPr>
           <a:xfrm>
             <a:off x="658368" y="320040"/>
-            <a:ext cx="8046720" cy="457200"/>
+            <a:ext cx="8046720" cy="658368"/>
           </a:xfrm>
           <a:prstGeom prst="rect">
             <a:avLst/>
@@ -11644,7 +12236,7 @@
               <a:buNone/>
             </a:pPr>
             <a:r>
-              <a:rPr lang="en-US" sz="3000" b="1" dirty="0">
+              <a:rPr lang="en-US" sz="3600" b="1" dirty="0">
                 <a:solidFill>
                   <a:srgbClr val="065A82"/>
                 </a:solidFill>
@@ -11723,6 +12315,10 @@
             <a:prstDash val="solid"/>
           </a:ln>
         </p:spPr>
+        <p:txBody>
+          <a:bodyPr/>
+          <a:p/>
+        </p:txBody>
       </p:sp>
       <p:sp>
         <p:nvSpPr>
@@ -11786,6 +12382,10 @@
             <a:prstDash val="solid"/>
           </a:ln>
         </p:spPr>
+        <p:txBody>
+          <a:bodyPr/>
+          <a:p/>
+        </p:txBody>
       </p:sp>
       <p:sp>
         <p:nvSpPr>
@@ -11811,6 +12411,10 @@
             <a:prstDash val="solid"/>
           </a:ln>
         </p:spPr>
+        <p:txBody>
+          <a:bodyPr/>
+          <a:p/>
+        </p:txBody>
       </p:sp>
       <p:sp>
         <p:nvSpPr>
@@ -11948,6 +12552,10 @@
             <a:prstDash val="solid"/>
           </a:ln>
         </p:spPr>
+        <p:txBody>
+          <a:bodyPr/>
+          <a:p/>
+        </p:txBody>
       </p:sp>
       <p:sp>
         <p:nvSpPr>
@@ -11973,6 +12581,10 @@
             <a:prstDash val="solid"/>
           </a:ln>
         </p:spPr>
+        <p:txBody>
+          <a:bodyPr/>
+          <a:p/>
+        </p:txBody>
       </p:sp>
       <p:sp>
         <p:nvSpPr>
@@ -12110,6 +12722,10 @@
             <a:prstDash val="solid"/>
           </a:ln>
         </p:spPr>
+        <p:txBody>
+          <a:bodyPr/>
+          <a:p/>
+        </p:txBody>
       </p:sp>
       <p:sp>
         <p:nvSpPr>
@@ -12135,6 +12751,10 @@
             <a:prstDash val="solid"/>
           </a:ln>
         </p:spPr>
+        <p:txBody>
+          <a:bodyPr/>
+          <a:p/>
+        </p:txBody>
       </p:sp>
       <p:sp>
         <p:nvSpPr>
@@ -12272,6 +12892,10 @@
             <a:prstDash val="solid"/>
           </a:ln>
         </p:spPr>
+        <p:txBody>
+          <a:bodyPr/>
+          <a:p/>
+        </p:txBody>
       </p:sp>
       <p:sp>
         <p:nvSpPr>
@@ -12297,6 +12921,10 @@
             <a:prstDash val="solid"/>
           </a:ln>
         </p:spPr>
+        <p:txBody>
+          <a:bodyPr/>
+          <a:p/>
+        </p:txBody>
       </p:sp>
       <p:sp>
         <p:nvSpPr>
@@ -12434,6 +13062,10 @@
             <a:prstDash val="solid"/>
           </a:ln>
         </p:spPr>
+        <p:txBody>
+          <a:bodyPr/>
+          <a:p/>
+        </p:txBody>
       </p:sp>
       <p:sp>
         <p:nvSpPr>
@@ -12459,6 +13091,10 @@
             <a:prstDash val="solid"/>
           </a:ln>
         </p:spPr>
+        <p:txBody>
+          <a:bodyPr/>
+          <a:p/>
+        </p:txBody>
       </p:sp>
       <p:sp>
         <p:nvSpPr>

</xml_diff>